<commit_message>
WK5 과제·투자피칭 PPT: Place/Promotion/People 균형 보강 + PPT에도 AI Agent 비중 반영
docx: 7P의 Place·Promotion·People 세 항목에도 [보험 AI Agent]/[블록체인
자동화] 태그를 적용해 나머지 항목(Product·Price·Physical Evidence)과
균형을 맞춤.

pptx: 슬라이드10(신규 상품 11종) 제목에 "AI·블록체인"을 명시하고,
슬라이드14(비즈니스모델 5유형)의 연속성 수익 카드에 "AI Assistant·
언더라이팅 엔진 라이선스"를 B2B 온체인 API보다 앞에 명시해 AI Agent
매출원이 블록체인 매출원과 동등하게 드러나도록 보강.

Co-Authored-By: Claude Sonnet 5 <noreply@anthropic.com>
Claude-Session: https://claude.ai/code/session_01GWDw6RThqmd55xBWQoyq5w
</commit_message>
<xml_diff>
--- a/인슈어체인_투자피칭_발표자료.pptx
+++ b/인슈어체인_투자피칭_발표자료.pptx
@@ -3681,7 +3681,7 @@
                 <a:ea typeface="Cambria" pitchFamily="34" charset="-122"/>
                 <a:cs typeface="Cambria" pitchFamily="34" charset="-120"/>
               </a:rPr>
-              <a:t>제품 — 블록체인 자동화 11개 신규 상품·고도화 기능 (대표 6종)</a:t>
+              <a:t>제품 — AI·블록체인 자동화 11개 신규 상품·고도화 기능 (대표 6종)</a:t>
             </a:r>
             <a:endParaRPr lang="en-US" sz="3000" dirty="0"/>
           </a:p>
@@ -6833,7 +6833,7 @@
                 <a:ea typeface="Calibri" pitchFamily="34" charset="-122"/>
                 <a:cs typeface="Calibri" pitchFamily="34" charset="-120"/>
               </a:rPr>
-              <a:t>B2B API 월정산·라이선스 유지보수료·재보험풀 AUM 수수료</a:t>
+              <a:t>AI Assistant·언더라이팅 엔진 라이선스, B2B 온체인 API 월정산, 재보험풀 AUM 수수료</a:t>
             </a:r>
             <a:endParaRPr lang="en-US" sz="1050" dirty="0"/>
           </a:p>

</xml_diff>